<commit_message>
Created the map plots for the sensitivity analysis
</commit_message>
<xml_diff>
--- a/chapter_07/figures/case_study_spain.pptx
+++ b/chapter_07/figures/case_study_spain.pptx
@@ -3246,12 +3246,12 @@
   <pc:docChgLst>
     <pc:chgData name="Fatima Pillosu" userId="a6295d4dc9e22643" providerId="LiveId" clId="{186C5A79-2432-4CC1-AF00-1868033951BA}"/>
     <pc:docChg chg="undo custSel addSld delSld modSld">
-      <pc:chgData name="Fatima Pillosu" userId="a6295d4dc9e22643" providerId="LiveId" clId="{186C5A79-2432-4CC1-AF00-1868033951BA}" dt="2025-07-12T22:30:33.810" v="1582" actId="20577"/>
+      <pc:chgData name="Fatima Pillosu" userId="a6295d4dc9e22643" providerId="LiveId" clId="{186C5A79-2432-4CC1-AF00-1868033951BA}" dt="2025-07-13T00:02:36.527" v="1586" actId="20577"/>
       <pc:docMkLst>
         <pc:docMk/>
       </pc:docMkLst>
       <pc:sldChg chg="addSp delSp modSp mod">
-        <pc:chgData name="Fatima Pillosu" userId="a6295d4dc9e22643" providerId="LiveId" clId="{186C5A79-2432-4CC1-AF00-1868033951BA}" dt="2025-07-12T22:30:33.810" v="1582" actId="20577"/>
+        <pc:chgData name="Fatima Pillosu" userId="a6295d4dc9e22643" providerId="LiveId" clId="{186C5A79-2432-4CC1-AF00-1868033951BA}" dt="2025-07-13T00:02:36.527" v="1586" actId="20577"/>
         <pc:sldMkLst>
           <pc:docMk/>
           <pc:sldMk cId="3134360065" sldId="256"/>
@@ -3361,7 +3361,7 @@
           </ac:spMkLst>
         </pc:spChg>
         <pc:spChg chg="mod">
-          <ac:chgData name="Fatima Pillosu" userId="a6295d4dc9e22643" providerId="LiveId" clId="{186C5A79-2432-4CC1-AF00-1868033951BA}" dt="2025-07-12T22:30:33.810" v="1582" actId="20577"/>
+          <ac:chgData name="Fatima Pillosu" userId="a6295d4dc9e22643" providerId="LiveId" clId="{186C5A79-2432-4CC1-AF00-1868033951BA}" dt="2025-07-13T00:02:36.527" v="1586" actId="20577"/>
           <ac:spMkLst>
             <pc:docMk/>
             <pc:sldMk cId="3134360065" sldId="256"/>
@@ -4400,7 +4400,7 @@
           <a:p>
             <a:fld id="{04C093FE-35F4-45C0-8951-9EAA4717686F}" type="datetimeFigureOut">
               <a:rPr lang="en-GB" smtClean="0"/>
-              <a:t>12/07/2025</a:t>
+              <a:t>13/07/2025</a:t>
             </a:fld>
             <a:endParaRPr lang="en-GB"/>
           </a:p>
@@ -4570,7 +4570,7 @@
           <a:p>
             <a:fld id="{04C093FE-35F4-45C0-8951-9EAA4717686F}" type="datetimeFigureOut">
               <a:rPr lang="en-GB" smtClean="0"/>
-              <a:t>12/07/2025</a:t>
+              <a:t>13/07/2025</a:t>
             </a:fld>
             <a:endParaRPr lang="en-GB"/>
           </a:p>
@@ -4750,7 +4750,7 @@
           <a:p>
             <a:fld id="{04C093FE-35F4-45C0-8951-9EAA4717686F}" type="datetimeFigureOut">
               <a:rPr lang="en-GB" smtClean="0"/>
-              <a:t>12/07/2025</a:t>
+              <a:t>13/07/2025</a:t>
             </a:fld>
             <a:endParaRPr lang="en-GB"/>
           </a:p>
@@ -4920,7 +4920,7 @@
           <a:p>
             <a:fld id="{04C093FE-35F4-45C0-8951-9EAA4717686F}" type="datetimeFigureOut">
               <a:rPr lang="en-GB" smtClean="0"/>
-              <a:t>12/07/2025</a:t>
+              <a:t>13/07/2025</a:t>
             </a:fld>
             <a:endParaRPr lang="en-GB"/>
           </a:p>
@@ -5166,7 +5166,7 @@
           <a:p>
             <a:fld id="{04C093FE-35F4-45C0-8951-9EAA4717686F}" type="datetimeFigureOut">
               <a:rPr lang="en-GB" smtClean="0"/>
-              <a:t>12/07/2025</a:t>
+              <a:t>13/07/2025</a:t>
             </a:fld>
             <a:endParaRPr lang="en-GB"/>
           </a:p>
@@ -5398,7 +5398,7 @@
           <a:p>
             <a:fld id="{04C093FE-35F4-45C0-8951-9EAA4717686F}" type="datetimeFigureOut">
               <a:rPr lang="en-GB" smtClean="0"/>
-              <a:t>12/07/2025</a:t>
+              <a:t>13/07/2025</a:t>
             </a:fld>
             <a:endParaRPr lang="en-GB"/>
           </a:p>
@@ -5765,7 +5765,7 @@
           <a:p>
             <a:fld id="{04C093FE-35F4-45C0-8951-9EAA4717686F}" type="datetimeFigureOut">
               <a:rPr lang="en-GB" smtClean="0"/>
-              <a:t>12/07/2025</a:t>
+              <a:t>13/07/2025</a:t>
             </a:fld>
             <a:endParaRPr lang="en-GB"/>
           </a:p>
@@ -5883,7 +5883,7 @@
           <a:p>
             <a:fld id="{04C093FE-35F4-45C0-8951-9EAA4717686F}" type="datetimeFigureOut">
               <a:rPr lang="en-GB" smtClean="0"/>
-              <a:t>12/07/2025</a:t>
+              <a:t>13/07/2025</a:t>
             </a:fld>
             <a:endParaRPr lang="en-GB"/>
           </a:p>
@@ -5978,7 +5978,7 @@
           <a:p>
             <a:fld id="{04C093FE-35F4-45C0-8951-9EAA4717686F}" type="datetimeFigureOut">
               <a:rPr lang="en-GB" smtClean="0"/>
-              <a:t>12/07/2025</a:t>
+              <a:t>13/07/2025</a:t>
             </a:fld>
             <a:endParaRPr lang="en-GB"/>
           </a:p>
@@ -6255,7 +6255,7 @@
           <a:p>
             <a:fld id="{04C093FE-35F4-45C0-8951-9EAA4717686F}" type="datetimeFigureOut">
               <a:rPr lang="en-GB" smtClean="0"/>
-              <a:t>12/07/2025</a:t>
+              <a:t>13/07/2025</a:t>
             </a:fld>
             <a:endParaRPr lang="en-GB"/>
           </a:p>
@@ -6512,7 +6512,7 @@
           <a:p>
             <a:fld id="{04C093FE-35F4-45C0-8951-9EAA4717686F}" type="datetimeFigureOut">
               <a:rPr lang="en-GB" smtClean="0"/>
-              <a:t>12/07/2025</a:t>
+              <a:t>13/07/2025</a:t>
             </a:fld>
             <a:endParaRPr lang="en-GB"/>
           </a:p>
@@ -6725,7 +6725,7 @@
           <a:p>
             <a:fld id="{04C093FE-35F4-45C0-8951-9EAA4717686F}" type="datetimeFigureOut">
               <a:rPr lang="en-GB" smtClean="0"/>
-              <a:t>12/07/2025</a:t>
+              <a:t>13/07/2025</a:t>
             </a:fld>
             <a:endParaRPr lang="en-GB"/>
           </a:p>
@@ -7166,30 +7166,30 @@
                 <a:latin typeface="Calibri" panose="020F0502020204030204" pitchFamily="34" charset="0"/>
                 <a:cs typeface="Calibri" panose="020F0502020204030204" pitchFamily="34" charset="0"/>
               </a:rPr>
-              <a:t>Flash floods in Spain in </a:t>
-            </a:r>
-            <a:r>
-              <a:rPr lang="en-US" sz="1200" b="1">
+              <a:t>Flash floods in Spain in October 2024</a:t>
+            </a:r>
+          </a:p>
+          <a:p>
+            <a:r>
+              <a:rPr lang="en-US" sz="1000" dirty="0">
                 <a:solidFill>
                   <a:srgbClr val="333333"/>
                 </a:solidFill>
-                <a:latin typeface="Calibri" panose="020F0502020204030204" pitchFamily="34" charset="0"/>
-                <a:cs typeface="Calibri" panose="020F0502020204030204" pitchFamily="34" charset="0"/>
-              </a:rPr>
-              <a:t>October 202</a:t>
-            </a:r>
-            <a:r>
-              <a:rPr lang="en-US" sz="1200" b="1" dirty="0">
+                <a:latin typeface="Calibri Light" panose="020F0302020204030204" pitchFamily="34" charset="0"/>
+                <a:cs typeface="Calibri Light" panose="020F0302020204030204" pitchFamily="34" charset="0"/>
+              </a:rPr>
+              <a:t>VT: from 2024-10-29 00 UTC </a:t>
+            </a:r>
+            <a:r>
+              <a:rPr lang="en-US" sz="1000">
                 <a:solidFill>
                   <a:srgbClr val="333333"/>
                 </a:solidFill>
-                <a:latin typeface="Calibri" panose="020F0502020204030204" pitchFamily="34" charset="0"/>
-                <a:cs typeface="Calibri" panose="020F0502020204030204" pitchFamily="34" charset="0"/>
-              </a:rPr>
-              <a:t>4</a:t>
-            </a:r>
-          </a:p>
-          <a:p>
+                <a:latin typeface="Calibri Light" panose="020F0302020204030204" pitchFamily="34" charset="0"/>
+                <a:cs typeface="Calibri Light" panose="020F0302020204030204" pitchFamily="34" charset="0"/>
+              </a:rPr>
+              <a:t>to 2024-10-30 </a:t>
+            </a:r>
             <a:r>
               <a:rPr lang="en-US" sz="1000" dirty="0">
                 <a:solidFill>
@@ -7198,7 +7198,7 @@
                 <a:latin typeface="Calibri Light" panose="020F0302020204030204" pitchFamily="34" charset="0"/>
                 <a:cs typeface="Calibri Light" panose="020F0302020204030204" pitchFamily="34" charset="0"/>
               </a:rPr>
-              <a:t>VT: from 2024-10-29 00 UTC to 2024-10-29 00 UTC</a:t>
+              <a:t>00 UTC</a:t>
             </a:r>
           </a:p>
         </p:txBody>

</xml_diff>